<commit_message>
fix(slides): resolve code-review layout overlaps + unused imports
- slide_cat_a row_height 0.38->0.35 to clear accent text overlap (HIGH)
- slide_overview accent text top 5.6->5.7 (MINOR overlap)
- drop unused Pt import (build script) and unused pytest import (test)

Co-Authored-By: Claude Opus 4.8 (1M context) <noreply@anthropic.com>
</commit_message>
<xml_diff>
--- a/docs/slides/2026-06-09-task-folder-inventory.pptx
+++ b/docs/slides/2026-06-09-task-folder-inventory.pptx
@@ -4067,7 +4067,7 @@
         </p:nvSpPr>
         <p:spPr>
           <a:xfrm>
-            <a:off x="548640" y="5120640"/>
+            <a:off x="548640" y="5212080"/>
             <a:ext cx="11064240" cy="914400"/>
           </a:xfrm>
           <a:prstGeom prst="rect">
@@ -4221,7 +4221,7 @@
         </p:nvGraphicFramePr>
         <p:xfrm>
           <a:off x="548640" y="1097280"/>
-          <a:ext cx="11064240" cy="4517136"/>
+          <a:ext cx="11064240" cy="4160520"/>
         </p:xfrm>
         <a:graphic>
           <a:graphicData uri="http://schemas.openxmlformats.org/drawingml/2006/table">
@@ -4234,7 +4234,7 @@
                 <a:gridCol w="5394960"/>
                 <a:gridCol w="1828800"/>
               </a:tblGrid>
-              <a:tr h="347472">
+              <a:tr h="320040">
                 <a:tc>
                   <a:txBody>
                     <a:bodyPr lIns="73152" rIns="73152"/>
@@ -4305,7 +4305,7 @@
                   </a:tcPr>
                 </a:tc>
               </a:tr>
-              <a:tr h="347472">
+              <a:tr h="320040">
                 <a:tc>
                   <a:txBody>
                     <a:bodyPr lIns="73152" rIns="73152"/>
@@ -4376,7 +4376,7 @@
                   </a:tcPr>
                 </a:tc>
               </a:tr>
-              <a:tr h="347472">
+              <a:tr h="320040">
                 <a:tc>
                   <a:txBody>
                     <a:bodyPr lIns="73152" rIns="73152"/>
@@ -4447,7 +4447,7 @@
                   </a:tcPr>
                 </a:tc>
               </a:tr>
-              <a:tr h="347472">
+              <a:tr h="320040">
                 <a:tc>
                   <a:txBody>
                     <a:bodyPr lIns="73152" rIns="73152"/>
@@ -4518,7 +4518,7 @@
                   </a:tcPr>
                 </a:tc>
               </a:tr>
-              <a:tr h="347472">
+              <a:tr h="320040">
                 <a:tc>
                   <a:txBody>
                     <a:bodyPr lIns="73152" rIns="73152"/>
@@ -4589,7 +4589,7 @@
                   </a:tcPr>
                 </a:tc>
               </a:tr>
-              <a:tr h="347472">
+              <a:tr h="320040">
                 <a:tc>
                   <a:txBody>
                     <a:bodyPr lIns="73152" rIns="73152"/>
@@ -4660,7 +4660,7 @@
                   </a:tcPr>
                 </a:tc>
               </a:tr>
-              <a:tr h="347472">
+              <a:tr h="320040">
                 <a:tc>
                   <a:txBody>
                     <a:bodyPr lIns="73152" rIns="73152"/>
@@ -4731,7 +4731,7 @@
                   </a:tcPr>
                 </a:tc>
               </a:tr>
-              <a:tr h="347472">
+              <a:tr h="320040">
                 <a:tc>
                   <a:txBody>
                     <a:bodyPr lIns="73152" rIns="73152"/>
@@ -4802,7 +4802,7 @@
                   </a:tcPr>
                 </a:tc>
               </a:tr>
-              <a:tr h="347472">
+              <a:tr h="320040">
                 <a:tc>
                   <a:txBody>
                     <a:bodyPr lIns="73152" rIns="73152"/>
@@ -4873,7 +4873,7 @@
                   </a:tcPr>
                 </a:tc>
               </a:tr>
-              <a:tr h="347472">
+              <a:tr h="320040">
                 <a:tc>
                   <a:txBody>
                     <a:bodyPr lIns="73152" rIns="73152"/>
@@ -4944,7 +4944,7 @@
                   </a:tcPr>
                 </a:tc>
               </a:tr>
-              <a:tr h="347472">
+              <a:tr h="320040">
                 <a:tc>
                   <a:txBody>
                     <a:bodyPr lIns="73152" rIns="73152"/>
@@ -5015,7 +5015,7 @@
                   </a:tcPr>
                 </a:tc>
               </a:tr>
-              <a:tr h="347472">
+              <a:tr h="320040">
                 <a:tc>
                   <a:txBody>
                     <a:bodyPr lIns="73152" rIns="73152"/>
@@ -5086,7 +5086,7 @@
                   </a:tcPr>
                 </a:tc>
               </a:tr>
-              <a:tr h="347472">
+              <a:tr h="320040">
                 <a:tc>
                   <a:txBody>
                     <a:bodyPr lIns="73152" rIns="73152"/>

</xml_diff>